<commit_message>
style: remove top-right mark and update chart styling for improved readability
</commit_message>
<xml_diff>
--- a/docs/presentation/file-3/slide-03-literature-scope.pptx
+++ b/docs/presentation/file-3/slide-03-literature-scope.pptx
@@ -2796,7 +2796,46 @@
         <p:spPr>
           <a:xfrm>
             <a:off x="7757160" y="1390650"/>
-            <a:ext cx="1695450" cy="752475"/>
+            <a:ext cx="304800" cy="752475"/>
+          </a:xfrm>
+          <a:prstGeom prst="rect">
+            <a:avLst/>
+          </a:prstGeom>
+          <a:noFill/>
+          <a:ln/>
+        </p:spPr>
+        <p:txBody>
+          <a:bodyPr wrap="square" lIns="0" tIns="0" rIns="0" bIns="0" rtlCol="0" anchor="ctr"/>
+          <a:lstStyle/>
+          <a:p>
+            <a:pPr algn="l" indent="0" marL="0">
+              <a:buNone/>
+            </a:pPr>
+            <a:r>
+              <a:rPr lang="en-US" sz="1050" b="1" dirty="0">
+                <a:solidFill>
+                  <a:srgbClr val="A8A39C"/>
+                </a:solidFill>
+                <a:latin typeface="IBM Plex Mono" pitchFamily="34" charset="0"/>
+                <a:ea typeface="IBM Plex Mono" pitchFamily="34" charset="-122"/>
+                <a:cs typeface="IBM Plex Mono" pitchFamily="34" charset="-120"/>
+              </a:rPr>
+              <a:t>01</a:t>
+            </a:r>
+            <a:endParaRPr lang="en-US" sz="1050" dirty="0"/>
+          </a:p>
+        </p:txBody>
+      </p:sp>
+      <p:sp>
+        <p:nvSpPr>
+          <p:cNvPr id="53" name="Text 51"/>
+          <p:cNvSpPr txBox="1"/>
+          <p:nvPr/>
+        </p:nvSpPr>
+        <p:spPr>
+          <a:xfrm>
+            <a:off x="8061960" y="1390650"/>
+            <a:ext cx="1362075" cy="752475"/>
           </a:xfrm>
           <a:prstGeom prst="rect">
             <a:avLst/>
@@ -2851,14 +2890,14 @@
       </p:sp>
       <p:sp>
         <p:nvSpPr>
-          <p:cNvPr id="53" name="Text 51"/>
-          <p:cNvSpPr txBox="1"/>
-          <p:nvPr/>
-        </p:nvSpPr>
-        <p:spPr>
-          <a:xfrm>
-            <a:off x="9566910" y="1390650"/>
-            <a:ext cx="1863090" cy="752475"/>
+          <p:cNvPr id="54" name="Text 52"/>
+          <p:cNvSpPr txBox="1"/>
+          <p:nvPr/>
+        </p:nvSpPr>
+        <p:spPr>
+          <a:xfrm>
+            <a:off x="9538335" y="1390650"/>
+            <a:ext cx="1891665" cy="752475"/>
           </a:xfrm>
           <a:prstGeom prst="rect">
             <a:avLst/>
@@ -2890,7 +2929,7 @@
       </p:sp>
       <p:sp>
         <p:nvSpPr>
-          <p:cNvPr id="54" name="Shape 52"/>
+          <p:cNvPr id="55" name="Shape 53"/>
           <p:cNvSpPr/>
           <p:nvPr/>
         </p:nvSpPr>
@@ -2913,14 +2952,53 @@
       </p:sp>
       <p:sp>
         <p:nvSpPr>
-          <p:cNvPr id="55" name="Text 53"/>
+          <p:cNvPr id="56" name="Text 54"/>
           <p:cNvSpPr txBox="1"/>
           <p:nvPr/>
         </p:nvSpPr>
         <p:spPr>
           <a:xfrm>
             <a:off x="7757160" y="2143125"/>
-            <a:ext cx="1695450" cy="752475"/>
+            <a:ext cx="304800" cy="752475"/>
+          </a:xfrm>
+          <a:prstGeom prst="rect">
+            <a:avLst/>
+          </a:prstGeom>
+          <a:noFill/>
+          <a:ln/>
+        </p:spPr>
+        <p:txBody>
+          <a:bodyPr wrap="square" lIns="0" tIns="0" rIns="0" bIns="0" rtlCol="0" anchor="ctr"/>
+          <a:lstStyle/>
+          <a:p>
+            <a:pPr algn="l" indent="0" marL="0">
+              <a:buNone/>
+            </a:pPr>
+            <a:r>
+              <a:rPr lang="en-US" sz="1050" b="1" dirty="0">
+                <a:solidFill>
+                  <a:srgbClr val="A8A39C"/>
+                </a:solidFill>
+                <a:latin typeface="IBM Plex Mono" pitchFamily="34" charset="0"/>
+                <a:ea typeface="IBM Plex Mono" pitchFamily="34" charset="-122"/>
+                <a:cs typeface="IBM Plex Mono" pitchFamily="34" charset="-120"/>
+              </a:rPr>
+              <a:t>02</a:t>
+            </a:r>
+            <a:endParaRPr lang="en-US" sz="1050" dirty="0"/>
+          </a:p>
+        </p:txBody>
+      </p:sp>
+      <p:sp>
+        <p:nvSpPr>
+          <p:cNvPr id="57" name="Text 55"/>
+          <p:cNvSpPr txBox="1"/>
+          <p:nvPr/>
+        </p:nvSpPr>
+        <p:spPr>
+          <a:xfrm>
+            <a:off x="8061960" y="2143125"/>
+            <a:ext cx="1362075" cy="752475"/>
           </a:xfrm>
           <a:prstGeom prst="rect">
             <a:avLst/>
@@ -2975,14 +3053,14 @@
       </p:sp>
       <p:sp>
         <p:nvSpPr>
-          <p:cNvPr id="56" name="Text 54"/>
-          <p:cNvSpPr txBox="1"/>
-          <p:nvPr/>
-        </p:nvSpPr>
-        <p:spPr>
-          <a:xfrm>
-            <a:off x="9566910" y="2143125"/>
-            <a:ext cx="1863090" cy="752475"/>
+          <p:cNvPr id="58" name="Text 56"/>
+          <p:cNvSpPr txBox="1"/>
+          <p:nvPr/>
+        </p:nvSpPr>
+        <p:spPr>
+          <a:xfrm>
+            <a:off x="9538335" y="2143125"/>
+            <a:ext cx="1891665" cy="752475"/>
           </a:xfrm>
           <a:prstGeom prst="rect">
             <a:avLst/>
@@ -3014,7 +3092,7 @@
       </p:sp>
       <p:sp>
         <p:nvSpPr>
-          <p:cNvPr id="57" name="Shape 55"/>
+          <p:cNvPr id="59" name="Shape 57"/>
           <p:cNvSpPr/>
           <p:nvPr/>
         </p:nvSpPr>
@@ -3048,7 +3126,7 @@
       </p:sp>
       <p:sp>
         <p:nvSpPr>
-          <p:cNvPr id="58" name="Shape 56"/>
+          <p:cNvPr id="60" name="Shape 58"/>
           <p:cNvSpPr/>
           <p:nvPr/>
         </p:nvSpPr>
@@ -3068,7 +3146,7 @@
       </p:sp>
       <p:sp>
         <p:nvSpPr>
-          <p:cNvPr id="59" name="Text 57"/>
+          <p:cNvPr id="61" name="Text 59"/>
           <p:cNvSpPr txBox="1"/>
           <p:nvPr/>
         </p:nvSpPr>
@@ -3107,7 +3185,7 @@
       </p:sp>
       <p:sp>
         <p:nvSpPr>
-          <p:cNvPr id="60" name="Text 58"/>
+          <p:cNvPr id="62" name="Text 60"/>
           <p:cNvSpPr txBox="1"/>
           <p:nvPr/>
         </p:nvSpPr>
@@ -3149,7 +3227,7 @@
       </p:sp>
       <p:sp>
         <p:nvSpPr>
-          <p:cNvPr id="61" name="Text 59"/>
+          <p:cNvPr id="63" name="Text 61"/>
           <p:cNvSpPr txBox="1"/>
           <p:nvPr/>
         </p:nvSpPr>
@@ -3191,7 +3269,7 @@
       </p:sp>
       <p:sp>
         <p:nvSpPr>
-          <p:cNvPr id="62" name="Shape 60"/>
+          <p:cNvPr id="64" name="Shape 62"/>
           <p:cNvSpPr/>
           <p:nvPr/>
         </p:nvSpPr>
@@ -3214,7 +3292,7 @@
       </p:sp>
       <p:sp>
         <p:nvSpPr>
-          <p:cNvPr id="63" name="Text 61"/>
+          <p:cNvPr id="65" name="Text 63"/>
           <p:cNvSpPr txBox="1"/>
           <p:nvPr/>
         </p:nvSpPr>
@@ -3253,7 +3331,7 @@
       </p:sp>
       <p:sp>
         <p:nvSpPr>
-          <p:cNvPr id="64" name="Shape 62"/>
+          <p:cNvPr id="66" name="Shape 64"/>
           <p:cNvSpPr/>
           <p:nvPr/>
         </p:nvSpPr>

</xml_diff>